<commit_message>
v2 Canva import assets
Co-Authored-By: Claude Fable 5.1 <noreply@anthropic.com>
Claude-Session: https://claude.ai/code/session_01Eb3RkpNphKpkaW5mmjMUEd
</commit_message>
<xml_diff>
--- a/Happy_Navratri_Greeting.pptx
+++ b/Happy_Navratri_Greeting.pptx
@@ -3088,61 +3088,9 @@
         <p:nvPr/>
       </p:nvGrpSpPr>
       <p:grpSpPr/>
-      <p:sp>
-        <p:nvSpPr>
-          <p:cNvPr id="2" name="Background"/>
-          <p:cNvSpPr/>
-          <p:nvPr/>
-        </p:nvSpPr>
-        <p:spPr>
-          <a:xfrm>
-            <a:off x="0" y="0"/>
-            <a:ext cx="10687050" cy="13354050"/>
-          </a:xfrm>
-          <a:prstGeom prst="rect">
-            <a:avLst/>
-          </a:prstGeom>
-          <a:gradFill rotWithShape="1">
-            <a:gsLst>
-              <a:gs pos="0">
-                <a:srgbClr val="721020"/>
-              </a:gs>
-              <a:gs pos="100000">
-                <a:srgbClr val="4E0711"/>
-              </a:gs>
-            </a:gsLst>
-            <a:lin scaled="0" ang="16200000"/>
-          </a:gradFill>
-          <a:ln>
-            <a:noFill/>
-          </a:ln>
-          <a:effectLst/>
-        </p:spPr>
-        <p:style>
-          <a:lnRef idx="1">
-            <a:schemeClr val="accent1"/>
-          </a:lnRef>
-          <a:fillRef idx="3">
-            <a:schemeClr val="accent1"/>
-          </a:fillRef>
-          <a:effectRef idx="2">
-            <a:schemeClr val="accent1"/>
-          </a:effectRef>
-          <a:fontRef idx="minor">
-            <a:schemeClr val="lt1"/>
-          </a:fontRef>
-        </p:style>
-        <p:txBody>
-          <a:bodyPr rtlCol="0" anchor="ctr"/>
-          <a:lstStyle/>
-          <a:p>
-            <a:pPr algn="ctr"/>
-          </a:p>
-        </p:txBody>
-      </p:sp>
       <p:pic>
         <p:nvPicPr>
-          <p:cNvPr id="3" name="Mandala bottom left" descr="mandala_bl.png"/>
+          <p:cNvPr id="2" name="Background" descr="greet_bg.png"/>
           <p:cNvPicPr>
             <a:picLocks noChangeAspect="1"/>
           </p:cNvPicPr>
@@ -3156,8 +3104,8 @@
         </p:blipFill>
         <p:spPr>
           <a:xfrm>
-            <a:off x="0" y="10210800"/>
-            <a:ext cx="3143250" cy="3143250"/>
+            <a:off x="0" y="0"/>
+            <a:ext cx="10687050" cy="13354050"/>
           </a:xfrm>
           <a:prstGeom prst="rect">
             <a:avLst/>
@@ -3166,7 +3114,7 @@
       </p:pic>
       <p:pic>
         <p:nvPicPr>
-          <p:cNvPr id="4" name="Mandala bottom right" descr="mandala_br.png"/>
+          <p:cNvPr id="3" name="Mandala bottom left" descr="mandala_BL.png"/>
           <p:cNvPicPr>
             <a:picLocks noChangeAspect="1"/>
           </p:cNvPicPr>
@@ -3180,8 +3128,8 @@
         </p:blipFill>
         <p:spPr>
           <a:xfrm>
-            <a:off x="7543800" y="10210800"/>
-            <a:ext cx="3143250" cy="3143250"/>
+            <a:off x="0" y="9782175"/>
+            <a:ext cx="3171825" cy="3571875"/>
           </a:xfrm>
           <a:prstGeom prst="rect">
             <a:avLst/>
@@ -3190,7 +3138,7 @@
       </p:pic>
       <p:pic>
         <p:nvPicPr>
-          <p:cNvPr id="5" name="Hanging diya chain L1" descr="chain.png"/>
+          <p:cNvPr id="4" name="Mandala bottom right" descr="mandala_BR.png"/>
           <p:cNvPicPr>
             <a:picLocks noChangeAspect="1"/>
           </p:cNvPicPr>
@@ -3204,8 +3152,8 @@
         </p:blipFill>
         <p:spPr>
           <a:xfrm>
-            <a:off x="552450" y="0"/>
-            <a:ext cx="590550" cy="4429125"/>
+            <a:off x="7515225" y="9782175"/>
+            <a:ext cx="3171825" cy="3571875"/>
           </a:xfrm>
           <a:prstGeom prst="rect">
             <a:avLst/>
@@ -3214,79 +3162,7 @@
       </p:pic>
       <p:pic>
         <p:nvPicPr>
-          <p:cNvPr id="6" name="Hanging diya chain L2" descr="chain.png"/>
-          <p:cNvPicPr>
-            <a:picLocks noChangeAspect="1"/>
-          </p:cNvPicPr>
-          <p:nvPr/>
-        </p:nvPicPr>
-        <p:blipFill>
-          <a:blip r:embed="rId4"/>
-          <a:stretch>
-            <a:fillRect/>
-          </a:stretch>
-        </p:blipFill>
-        <p:spPr>
-          <a:xfrm>
-            <a:off x="1352550" y="0"/>
-            <a:ext cx="590550" cy="4429125"/>
-          </a:xfrm>
-          <a:prstGeom prst="rect">
-            <a:avLst/>
-          </a:prstGeom>
-        </p:spPr>
-      </p:pic>
-      <p:pic>
-        <p:nvPicPr>
-          <p:cNvPr id="7" name="Hanging diya chain R1" descr="chain.png"/>
-          <p:cNvPicPr>
-            <a:picLocks noChangeAspect="1"/>
-          </p:cNvPicPr>
-          <p:nvPr/>
-        </p:nvPicPr>
-        <p:blipFill>
-          <a:blip r:embed="rId4"/>
-          <a:stretch>
-            <a:fillRect/>
-          </a:stretch>
-        </p:blipFill>
-        <p:spPr>
-          <a:xfrm>
-            <a:off x="9544050" y="0"/>
-            <a:ext cx="590550" cy="4429125"/>
-          </a:xfrm>
-          <a:prstGeom prst="rect">
-            <a:avLst/>
-          </a:prstGeom>
-        </p:spPr>
-      </p:pic>
-      <p:pic>
-        <p:nvPicPr>
-          <p:cNvPr id="8" name="Hanging diya chain R2" descr="chain.png"/>
-          <p:cNvPicPr>
-            <a:picLocks noChangeAspect="1"/>
-          </p:cNvPicPr>
-          <p:nvPr/>
-        </p:nvPicPr>
-        <p:blipFill>
-          <a:blip r:embed="rId4"/>
-          <a:stretch>
-            <a:fillRect/>
-          </a:stretch>
-        </p:blipFill>
-        <p:spPr>
-          <a:xfrm>
-            <a:off x="8743950" y="0"/>
-            <a:ext cx="590550" cy="4429125"/>
-          </a:xfrm>
-          <a:prstGeom prst="rect">
-            <a:avLst/>
-          </a:prstGeom>
-        </p:spPr>
-      </p:pic>
-      <p:pic>
-        <p:nvPicPr>
-          <p:cNvPr id="9" name="Star left" descr="star.png"/>
+          <p:cNvPr id="5" name="Hanging diya chain L1" descr="chain_L1.png"/>
           <p:cNvPicPr>
             <a:picLocks noChangeAspect="1"/>
           </p:cNvPicPr>
@@ -3300,8 +3176,8 @@
         </p:blipFill>
         <p:spPr>
           <a:xfrm>
-            <a:off x="628650" y="285750"/>
-            <a:ext cx="228600" cy="228600"/>
+            <a:off x="514350" y="0"/>
+            <a:ext cx="609600" cy="5076825"/>
           </a:xfrm>
           <a:prstGeom prst="rect">
             <a:avLst/>
@@ -3310,31 +3186,7 @@
       </p:pic>
       <p:pic>
         <p:nvPicPr>
-          <p:cNvPr id="10" name="Star right" descr="star.png"/>
-          <p:cNvPicPr>
-            <a:picLocks noChangeAspect="1"/>
-          </p:cNvPicPr>
-          <p:nvPr/>
-        </p:nvPicPr>
-        <p:blipFill>
-          <a:blip r:embed="rId5"/>
-          <a:stretch>
-            <a:fillRect/>
-          </a:stretch>
-        </p:blipFill>
-        <p:spPr>
-          <a:xfrm>
-            <a:off x="9829800" y="285750"/>
-            <a:ext cx="228600" cy="228600"/>
-          </a:xfrm>
-          <a:prstGeom prst="rect">
-            <a:avLst/>
-          </a:prstGeom>
-        </p:spPr>
-      </p:pic>
-      <p:pic>
-        <p:nvPicPr>
-          <p:cNvPr id="11" name="Durga eyes emblem" descr="eyes.png"/>
+          <p:cNvPr id="6" name="Hanging diya chain L2" descr="chain_L2.png"/>
           <p:cNvPicPr>
             <a:picLocks noChangeAspect="1"/>
           </p:cNvPicPr>
@@ -3348,23 +3200,95 @@
         </p:blipFill>
         <p:spPr>
           <a:xfrm>
-            <a:off x="2628900" y="3524250"/>
-            <a:ext cx="5429250" cy="2884289"/>
+            <a:off x="1285875" y="123825"/>
+            <a:ext cx="581025" cy="4019550"/>
           </a:xfrm>
           <a:prstGeom prst="rect">
             <a:avLst/>
           </a:prstGeom>
         </p:spPr>
       </p:pic>
-      <p:sp>
-        <p:nvSpPr>
-          <p:cNvPr id="12" name="Title"/>
+      <p:pic>
+        <p:nvPicPr>
+          <p:cNvPr id="7" name="Hanging diya chain R2" descr="chain_R2.png"/>
+          <p:cNvPicPr>
+            <a:picLocks noChangeAspect="1"/>
+          </p:cNvPicPr>
+          <p:nvPr/>
+        </p:nvPicPr>
+        <p:blipFill>
+          <a:blip r:embed="rId7"/>
+          <a:stretch>
+            <a:fillRect/>
+          </a:stretch>
+        </p:blipFill>
+        <p:spPr>
+          <a:xfrm>
+            <a:off x="8820150" y="123825"/>
+            <a:ext cx="581025" cy="4019550"/>
+          </a:xfrm>
+          <a:prstGeom prst="rect">
+            <a:avLst/>
+          </a:prstGeom>
+        </p:spPr>
+      </p:pic>
+      <p:pic>
+        <p:nvPicPr>
+          <p:cNvPr id="8" name="Hanging diya chain R1" descr="chain_R1.png"/>
+          <p:cNvPicPr>
+            <a:picLocks noChangeAspect="1"/>
+          </p:cNvPicPr>
+          <p:nvPr/>
+        </p:nvPicPr>
+        <p:blipFill>
+          <a:blip r:embed="rId8"/>
+          <a:stretch>
+            <a:fillRect/>
+          </a:stretch>
+        </p:blipFill>
+        <p:spPr>
+          <a:xfrm>
+            <a:off x="9563100" y="0"/>
+            <a:ext cx="609600" cy="5086350"/>
+          </a:xfrm>
+          <a:prstGeom prst="rect">
+            <a:avLst/>
+          </a:prstGeom>
+        </p:spPr>
+      </p:pic>
+      <p:pic>
+        <p:nvPicPr>
+          <p:cNvPr id="9" name="Durga eyes emblem" descr="eyes.png"/>
+          <p:cNvPicPr>
+            <a:picLocks noChangeAspect="1"/>
+          </p:cNvPicPr>
+          <p:nvPr/>
+        </p:nvPicPr>
+        <p:blipFill>
+          <a:blip r:embed="rId9"/>
+          <a:stretch>
+            <a:fillRect/>
+          </a:stretch>
+        </p:blipFill>
+        <p:spPr>
+          <a:xfrm>
+            <a:off x="2524125" y="3505200"/>
+            <a:ext cx="5648325" cy="3057525"/>
+          </a:xfrm>
+          <a:prstGeom prst="rect">
+            <a:avLst/>
+          </a:prstGeom>
+        </p:spPr>
+      </p:pic>
+      <p:sp>
+        <p:nvSpPr>
+          <p:cNvPr id="10" name="Title"/>
           <p:cNvSpPr txBox="1"/>
           <p:nvPr/>
         </p:nvSpPr>
         <p:spPr>
           <a:xfrm>
-            <a:off x="581025" y="6953250"/>
+            <a:off x="581025" y="6943725"/>
             <a:ext cx="9525000" cy="1428750"/>
           </a:xfrm>
           <a:prstGeom prst="rect">
@@ -3373,22 +3297,22 @@
           <a:noFill/>
         </p:spPr>
         <p:txBody>
-          <a:bodyPr wrap="square" lIns="0" rIns="0" tIns="0" bIns="0" anchor="t">
+          <a:bodyPr wrap="square" lIns="0" rIns="0" tIns="0" bIns="0">
             <a:spAutoFit/>
           </a:bodyPr>
           <a:lstStyle/>
           <a:p>
             <a:pPr algn="ctr">
               <a:lnSpc>
-                <a:spcPct val="115000"/>
+                <a:spcPct val="100000"/>
               </a:lnSpc>
             </a:pPr>
             <a:r>
-              <a:rPr sz="8850" b="1" spc="-200">
+              <a:rPr sz="9300" b="0">
                 <a:solidFill>
-                  <a:srgbClr val="F2DFA7"/>
+                  <a:srgbClr val="F5E6B3"/>
                 </a:solidFill>
-                <a:latin typeface="Playfair Display"/>
+                <a:latin typeface="DM Serif Display"/>
               </a:rPr>
               <a:t>Happy Navratri</a:t>
             </a:r>
@@ -3397,14 +3321,14 @@
       </p:sp>
       <p:sp>
         <p:nvSpPr>
-          <p:cNvPr id="13" name="Greeting message"/>
+          <p:cNvPr id="11" name="Greeting message"/>
           <p:cNvSpPr txBox="1"/>
           <p:nvPr/>
         </p:nvSpPr>
         <p:spPr>
           <a:xfrm>
-            <a:off x="962025" y="8553450"/>
-            <a:ext cx="8763000" cy="952500"/>
+            <a:off x="962025" y="8648700"/>
+            <a:ext cx="8763000" cy="1047750"/>
           </a:xfrm>
           <a:prstGeom prst="rect">
             <a:avLst/>
@@ -3412,22 +3336,22 @@
           <a:noFill/>
         </p:spPr>
         <p:txBody>
-          <a:bodyPr wrap="square" lIns="0" rIns="0" tIns="0" bIns="0" anchor="t">
+          <a:bodyPr wrap="square" lIns="0" rIns="0" tIns="0" bIns="0">
             <a:spAutoFit/>
           </a:bodyPr>
           <a:lstStyle/>
           <a:p>
             <a:pPr algn="ctr">
               <a:lnSpc>
-                <a:spcPct val="125000"/>
+                <a:spcPct val="120000"/>
               </a:lnSpc>
             </a:pPr>
             <a:r>
-              <a:rPr sz="2400" b="0">
+              <a:rPr sz="2700" b="0">
                 <a:solidFill>
-                  <a:srgbClr val="F2DFA7"/>
+                  <a:srgbClr val="F5E6B3"/>
                 </a:solidFill>
-                <a:latin typeface="Open Sans"/>
+                <a:latin typeface="Calibri"/>
               </a:rPr>
               <a:t>On this auspicious day of Navratri, we wish that Durga</a:t>
             </a:r>
@@ -3435,15 +3359,15 @@
           <a:p>
             <a:pPr algn="ctr">
               <a:lnSpc>
-                <a:spcPct val="125000"/>
+                <a:spcPct val="120000"/>
               </a:lnSpc>
             </a:pPr>
             <a:r>
-              <a:rPr sz="2400" b="0">
+              <a:rPr sz="2700" b="0">
                 <a:solidFill>
-                  <a:srgbClr val="F2DFA7"/>
+                  <a:srgbClr val="F5E6B3"/>
                 </a:solidFill>
-                <a:latin typeface="Open Sans"/>
+                <a:latin typeface="Calibri"/>
               </a:rPr>
               <a:t>Devi shower upon her divine blessings on you.</a:t>
             </a:r>

</xml_diff>